<commit_message>
vault backup: 2026-07-19 18:57:27
</commit_message>
<xml_diff>
--- a/assets/03-gpuaas/image.pptx
+++ b/assets/03-gpuaas/image.pptx
@@ -13,6 +13,12 @@
     <p:sldId id="380" r:id="rId7"/>
     <p:sldId id="381" r:id="rId8"/>
     <p:sldId id="382" r:id="rId9"/>
+    <p:sldId id="383" r:id="rId10"/>
+    <p:sldId id="388" r:id="rId11"/>
+    <p:sldId id="384" r:id="rId12"/>
+    <p:sldId id="385" r:id="rId13"/>
+    <p:sldId id="386" r:id="rId14"/>
+    <p:sldId id="387" r:id="rId15"/>
   </p:sldIdLst>
   <p:sldSz cx="12192000" cy="6858000"/>
   <p:notesSz cx="6858000" cy="9144000"/>
@@ -122,7 +128,7 @@
 <file path=ppt/revisionInfo.xml><?xml version="1.0" encoding="utf-8"?>
 <p1510:revInfo xmlns:a="http://schemas.openxmlformats.org/drawingml/2006/main" xmlns:r="http://schemas.openxmlformats.org/officeDocument/2006/relationships" xmlns:p1510="http://schemas.microsoft.com/office/powerpoint/2015/10/main">
   <p1510:revLst>
-    <p1510:client id="{55B79FC3-CAA5-440E-91EB-3C0F908AF9C6}" v="2" dt="2026-07-19T09:11:25.955"/>
+    <p1510:client id="{55B79FC3-CAA5-440E-91EB-3C0F908AF9C6}" v="4" dt="2026-07-19T09:49:19.339"/>
   </p1510:revLst>
 </p1510:revInfo>
 </file>
@@ -132,7 +138,7 @@
   <pc:docChgLst>
     <pc:chgData name="헌정 임" userId="eb9ca9bd79f0560f" providerId="LiveId" clId="{A6339E56-8272-42D6-9D95-12E1A8284411}"/>
     <pc:docChg chg="undo custSel addSld delSld modSld sldOrd">
-      <pc:chgData name="헌정 임" userId="eb9ca9bd79f0560f" providerId="LiveId" clId="{A6339E56-8272-42D6-9D95-12E1A8284411}" dt="2026-07-19T09:11:50.311" v="7330" actId="1076"/>
+      <pc:chgData name="헌정 임" userId="eb9ca9bd79f0560f" providerId="LiveId" clId="{A6339E56-8272-42D6-9D95-12E1A8284411}" dt="2026-07-19T09:56:08.190" v="7371" actId="208"/>
       <pc:docMkLst>
         <pc:docMk/>
       </pc:docMkLst>
@@ -179,7 +185,7 @@
         </pc:sldMkLst>
       </pc:sldChg>
       <pc:sldChg chg="addSp delSp modSp new mod">
-        <pc:chgData name="헌정 임" userId="eb9ca9bd79f0560f" providerId="LiveId" clId="{A6339E56-8272-42D6-9D95-12E1A8284411}" dt="2026-07-19T09:05:05.644" v="7320" actId="208"/>
+        <pc:chgData name="헌정 임" userId="eb9ca9bd79f0560f" providerId="LiveId" clId="{A6339E56-8272-42D6-9D95-12E1A8284411}" dt="2026-07-19T09:49:23.568" v="7349" actId="14100"/>
         <pc:sldMkLst>
           <pc:docMk/>
           <pc:sldMk cId="1569238058" sldId="381"/>
@@ -201,7 +207,7 @@
           </ac:spMkLst>
         </pc:spChg>
         <pc:spChg chg="add mod">
-          <ac:chgData name="헌정 임" userId="eb9ca9bd79f0560f" providerId="LiveId" clId="{A6339E56-8272-42D6-9D95-12E1A8284411}" dt="2026-07-19T09:04:22.127" v="7313" actId="1036"/>
+          <ac:chgData name="헌정 임" userId="eb9ca9bd79f0560f" providerId="LiveId" clId="{A6339E56-8272-42D6-9D95-12E1A8284411}" dt="2026-07-19T09:48:56.287" v="7331" actId="1076"/>
           <ac:spMkLst>
             <pc:docMk/>
             <pc:sldMk cId="1569238058" sldId="381"/>
@@ -209,7 +215,7 @@
           </ac:spMkLst>
         </pc:spChg>
         <pc:spChg chg="add mod">
-          <ac:chgData name="헌정 임" userId="eb9ca9bd79f0560f" providerId="LiveId" clId="{A6339E56-8272-42D6-9D95-12E1A8284411}" dt="2026-07-19T09:04:25.249" v="7314" actId="571"/>
+          <ac:chgData name="헌정 임" userId="eb9ca9bd79f0560f" providerId="LiveId" clId="{A6339E56-8272-42D6-9D95-12E1A8284411}" dt="2026-07-19T09:48:56.287" v="7331" actId="1076"/>
           <ac:spMkLst>
             <pc:docMk/>
             <pc:sldMk cId="1569238058" sldId="381"/>
@@ -217,15 +223,31 @@
           </ac:spMkLst>
         </pc:spChg>
         <pc:spChg chg="add mod">
-          <ac:chgData name="헌정 임" userId="eb9ca9bd79f0560f" providerId="LiveId" clId="{A6339E56-8272-42D6-9D95-12E1A8284411}" dt="2026-07-19T09:05:05.644" v="7320" actId="208"/>
+          <ac:chgData name="헌정 임" userId="eb9ca9bd79f0560f" providerId="LiveId" clId="{A6339E56-8272-42D6-9D95-12E1A8284411}" dt="2026-07-19T09:48:56.287" v="7331" actId="1076"/>
           <ac:spMkLst>
             <pc:docMk/>
             <pc:sldMk cId="1569238058" sldId="381"/>
             <ac:spMk id="10" creationId="{DAEAA0BA-A8E1-F822-7E3A-134E2D689C56}"/>
           </ac:spMkLst>
         </pc:spChg>
-        <pc:picChg chg="add">
-          <ac:chgData name="헌정 임" userId="eb9ca9bd79f0560f" providerId="LiveId" clId="{A6339E56-8272-42D6-9D95-12E1A8284411}" dt="2026-07-19T09:04:02.117" v="7303" actId="22"/>
+        <pc:spChg chg="add mod">
+          <ac:chgData name="헌정 임" userId="eb9ca9bd79f0560f" providerId="LiveId" clId="{A6339E56-8272-42D6-9D95-12E1A8284411}" dt="2026-07-19T09:49:13.019" v="7344" actId="1038"/>
+          <ac:spMkLst>
+            <pc:docMk/>
+            <pc:sldMk cId="1569238058" sldId="381"/>
+            <ac:spMk id="15" creationId="{B1D90B6C-02CD-90EE-D948-E49CC7BA57B5}"/>
+          </ac:spMkLst>
+        </pc:spChg>
+        <pc:spChg chg="add mod">
+          <ac:chgData name="헌정 임" userId="eb9ca9bd79f0560f" providerId="LiveId" clId="{A6339E56-8272-42D6-9D95-12E1A8284411}" dt="2026-07-19T09:49:23.568" v="7349" actId="14100"/>
+          <ac:spMkLst>
+            <pc:docMk/>
+            <pc:sldMk cId="1569238058" sldId="381"/>
+            <ac:spMk id="17" creationId="{C4FAD7A7-0F1B-7E16-5798-9E7DBC28CCA9}"/>
+          </ac:spMkLst>
+        </pc:spChg>
+        <pc:picChg chg="add mod">
+          <ac:chgData name="헌정 임" userId="eb9ca9bd79f0560f" providerId="LiveId" clId="{A6339E56-8272-42D6-9D95-12E1A8284411}" dt="2026-07-19T09:48:56.287" v="7331" actId="1076"/>
           <ac:picMkLst>
             <pc:docMk/>
             <pc:sldMk cId="1569238058" sldId="381"/>
@@ -233,11 +255,27 @@
           </ac:picMkLst>
         </pc:picChg>
         <pc:picChg chg="add mod">
-          <ac:chgData name="헌정 임" userId="eb9ca9bd79f0560f" providerId="LiveId" clId="{A6339E56-8272-42D6-9D95-12E1A8284411}" dt="2026-07-19T09:04:59.241" v="7319" actId="1076"/>
+          <ac:chgData name="헌정 임" userId="eb9ca9bd79f0560f" providerId="LiveId" clId="{A6339E56-8272-42D6-9D95-12E1A8284411}" dt="2026-07-19T09:48:56.287" v="7331" actId="1076"/>
           <ac:picMkLst>
             <pc:docMk/>
             <pc:sldMk cId="1569238058" sldId="381"/>
             <ac:picMk id="12" creationId="{30580836-3275-1CFF-AAB8-39945B62DDF2}"/>
+          </ac:picMkLst>
+        </pc:picChg>
+        <pc:picChg chg="add mod">
+          <ac:chgData name="헌정 임" userId="eb9ca9bd79f0560f" providerId="LiveId" clId="{A6339E56-8272-42D6-9D95-12E1A8284411}" dt="2026-07-19T09:48:59.383" v="7333" actId="1076"/>
+          <ac:picMkLst>
+            <pc:docMk/>
+            <pc:sldMk cId="1569238058" sldId="381"/>
+            <ac:picMk id="14" creationId="{5BBC49ED-5FBB-9032-DBF6-B6DF5726A3D1}"/>
+          </ac:picMkLst>
+        </pc:picChg>
+        <pc:picChg chg="add mod">
+          <ac:chgData name="헌정 임" userId="eb9ca9bd79f0560f" providerId="LiveId" clId="{A6339E56-8272-42D6-9D95-12E1A8284411}" dt="2026-07-19T09:49:13.019" v="7344" actId="1038"/>
+          <ac:picMkLst>
+            <pc:docMk/>
+            <pc:sldMk cId="1569238058" sldId="381"/>
+            <ac:picMk id="16" creationId="{8E510375-6981-5337-504F-272B07192137}"/>
           </ac:picMkLst>
         </pc:picChg>
       </pc:sldChg>
@@ -285,6 +323,120 @@
             <pc:docMk/>
             <pc:sldMk cId="708211789" sldId="382"/>
             <ac:picMk id="8" creationId="{98E53782-11BD-C8C9-2433-2FE41AEB5E7B}"/>
+          </ac:picMkLst>
+        </pc:picChg>
+      </pc:sldChg>
+      <pc:sldChg chg="addSp delSp modSp new mod">
+        <pc:chgData name="헌정 임" userId="eb9ca9bd79f0560f" providerId="LiveId" clId="{A6339E56-8272-42D6-9D95-12E1A8284411}" dt="2026-07-19T09:54:43.926" v="7366" actId="208"/>
+        <pc:sldMkLst>
+          <pc:docMk/>
+          <pc:sldMk cId="1939488093" sldId="383"/>
+        </pc:sldMkLst>
+        <pc:spChg chg="del">
+          <ac:chgData name="헌정 임" userId="eb9ca9bd79f0560f" providerId="LiveId" clId="{A6339E56-8272-42D6-9D95-12E1A8284411}" dt="2026-07-19T09:51:20.301" v="7351" actId="478"/>
+          <ac:spMkLst>
+            <pc:docMk/>
+            <pc:sldMk cId="1939488093" sldId="383"/>
+            <ac:spMk id="2" creationId="{2870B017-1821-AB1B-7445-6B8DE3BAE722}"/>
+          </ac:spMkLst>
+        </pc:spChg>
+        <pc:spChg chg="del">
+          <ac:chgData name="헌정 임" userId="eb9ca9bd79f0560f" providerId="LiveId" clId="{A6339E56-8272-42D6-9D95-12E1A8284411}" dt="2026-07-19T09:51:20.301" v="7351" actId="478"/>
+          <ac:spMkLst>
+            <pc:docMk/>
+            <pc:sldMk cId="1939488093" sldId="383"/>
+            <ac:spMk id="3" creationId="{241A4EC8-75FD-02B6-B72B-A6C694D2BCD5}"/>
+          </ac:spMkLst>
+        </pc:spChg>
+        <pc:picChg chg="add mod">
+          <ac:chgData name="헌정 임" userId="eb9ca9bd79f0560f" providerId="LiveId" clId="{A6339E56-8272-42D6-9D95-12E1A8284411}" dt="2026-07-19T09:54:43.926" v="7366" actId="208"/>
+          <ac:picMkLst>
+            <pc:docMk/>
+            <pc:sldMk cId="1939488093" sldId="383"/>
+            <ac:picMk id="5" creationId="{376F8DE8-B3D5-3EFB-E1C5-850A5BA0A308}"/>
+          </ac:picMkLst>
+        </pc:picChg>
+        <pc:picChg chg="add del">
+          <ac:chgData name="헌정 임" userId="eb9ca9bd79f0560f" providerId="LiveId" clId="{A6339E56-8272-42D6-9D95-12E1A8284411}" dt="2026-07-19T09:54:36.308" v="7364" actId="21"/>
+          <ac:picMkLst>
+            <pc:docMk/>
+            <pc:sldMk cId="1939488093" sldId="383"/>
+            <ac:picMk id="7" creationId="{B6BA9DD1-10C7-44D9-0B1E-E2DEBB02060A}"/>
+          </ac:picMkLst>
+        </pc:picChg>
+      </pc:sldChg>
+      <pc:sldChg chg="addSp modSp new mod">
+        <pc:chgData name="헌정 임" userId="eb9ca9bd79f0560f" providerId="LiveId" clId="{A6339E56-8272-42D6-9D95-12E1A8284411}" dt="2026-07-19T09:55:25.678" v="7368" actId="208"/>
+        <pc:sldMkLst>
+          <pc:docMk/>
+          <pc:sldMk cId="39534546" sldId="384"/>
+        </pc:sldMkLst>
+        <pc:picChg chg="add mod">
+          <ac:chgData name="헌정 임" userId="eb9ca9bd79f0560f" providerId="LiveId" clId="{A6339E56-8272-42D6-9D95-12E1A8284411}" dt="2026-07-19T09:55:25.678" v="7368" actId="208"/>
+          <ac:picMkLst>
+            <pc:docMk/>
+            <pc:sldMk cId="39534546" sldId="384"/>
+            <ac:picMk id="5" creationId="{E4E5C907-055A-FB63-1428-F49E1DE22A51}"/>
+          </ac:picMkLst>
+        </pc:picChg>
+      </pc:sldChg>
+      <pc:sldChg chg="addSp modSp new mod">
+        <pc:chgData name="헌정 임" userId="eb9ca9bd79f0560f" providerId="LiveId" clId="{A6339E56-8272-42D6-9D95-12E1A8284411}" dt="2026-07-19T09:55:39.342" v="7369" actId="208"/>
+        <pc:sldMkLst>
+          <pc:docMk/>
+          <pc:sldMk cId="3081685535" sldId="385"/>
+        </pc:sldMkLst>
+        <pc:picChg chg="add mod">
+          <ac:chgData name="헌정 임" userId="eb9ca9bd79f0560f" providerId="LiveId" clId="{A6339E56-8272-42D6-9D95-12E1A8284411}" dt="2026-07-19T09:55:39.342" v="7369" actId="208"/>
+          <ac:picMkLst>
+            <pc:docMk/>
+            <pc:sldMk cId="3081685535" sldId="385"/>
+            <ac:picMk id="5" creationId="{F66728A3-E049-6A90-0CDC-129F74A5D227}"/>
+          </ac:picMkLst>
+        </pc:picChg>
+      </pc:sldChg>
+      <pc:sldChg chg="addSp modSp new mod">
+        <pc:chgData name="헌정 임" userId="eb9ca9bd79f0560f" providerId="LiveId" clId="{A6339E56-8272-42D6-9D95-12E1A8284411}" dt="2026-07-19T09:55:54.018" v="7370" actId="208"/>
+        <pc:sldMkLst>
+          <pc:docMk/>
+          <pc:sldMk cId="7217532" sldId="386"/>
+        </pc:sldMkLst>
+        <pc:picChg chg="add mod">
+          <ac:chgData name="헌정 임" userId="eb9ca9bd79f0560f" providerId="LiveId" clId="{A6339E56-8272-42D6-9D95-12E1A8284411}" dt="2026-07-19T09:55:54.018" v="7370" actId="208"/>
+          <ac:picMkLst>
+            <pc:docMk/>
+            <pc:sldMk cId="7217532" sldId="386"/>
+            <ac:picMk id="5" creationId="{B86A4D6D-C99D-49AF-201F-6B402441A717}"/>
+          </ac:picMkLst>
+        </pc:picChg>
+      </pc:sldChg>
+      <pc:sldChg chg="addSp modSp new mod">
+        <pc:chgData name="헌정 임" userId="eb9ca9bd79f0560f" providerId="LiveId" clId="{A6339E56-8272-42D6-9D95-12E1A8284411}" dt="2026-07-19T09:56:08.190" v="7371" actId="208"/>
+        <pc:sldMkLst>
+          <pc:docMk/>
+          <pc:sldMk cId="151827556" sldId="387"/>
+        </pc:sldMkLst>
+        <pc:picChg chg="add mod">
+          <ac:chgData name="헌정 임" userId="eb9ca9bd79f0560f" providerId="LiveId" clId="{A6339E56-8272-42D6-9D95-12E1A8284411}" dt="2026-07-19T09:56:08.190" v="7371" actId="208"/>
+          <ac:picMkLst>
+            <pc:docMk/>
+            <pc:sldMk cId="151827556" sldId="387"/>
+            <ac:picMk id="5" creationId="{2C170D42-EEE7-0463-1A57-ADEE87F1CDA8}"/>
+          </ac:picMkLst>
+        </pc:picChg>
+      </pc:sldChg>
+      <pc:sldChg chg="addSp modSp new mod">
+        <pc:chgData name="헌정 임" userId="eb9ca9bd79f0560f" providerId="LiveId" clId="{A6339E56-8272-42D6-9D95-12E1A8284411}" dt="2026-07-19T09:55:06.773" v="7367" actId="208"/>
+        <pc:sldMkLst>
+          <pc:docMk/>
+          <pc:sldMk cId="861741968" sldId="388"/>
+        </pc:sldMkLst>
+        <pc:picChg chg="add mod">
+          <ac:chgData name="헌정 임" userId="eb9ca9bd79f0560f" providerId="LiveId" clId="{A6339E56-8272-42D6-9D95-12E1A8284411}" dt="2026-07-19T09:55:06.773" v="7367" actId="208"/>
+          <ac:picMkLst>
+            <pc:docMk/>
+            <pc:sldMk cId="861741968" sldId="388"/>
+            <ac:picMk id="5" creationId="{09F8A439-CCD9-D3A9-FA3A-D48E9AC4BB2F}"/>
           </ac:picMkLst>
         </pc:picChg>
       </pc:sldChg>
@@ -3707,6 +3859,591 @@
 </p:sld>
 </file>
 
+<file path=ppt/slides/slide10.xml><?xml version="1.0" encoding="utf-8"?>
+<p:sld xmlns:a="http://schemas.openxmlformats.org/drawingml/2006/main" xmlns:r="http://schemas.openxmlformats.org/officeDocument/2006/relationships" xmlns:p="http://schemas.openxmlformats.org/presentationml/2006/main">
+  <p:cSld>
+    <p:spTree>
+      <p:nvGrpSpPr>
+        <p:cNvPr id="1" name=""/>
+        <p:cNvGrpSpPr/>
+        <p:nvPr/>
+      </p:nvGrpSpPr>
+      <p:grpSpPr>
+        <a:xfrm>
+          <a:off x="0" y="0"/>
+          <a:ext cx="0" cy="0"/>
+          <a:chOff x="0" y="0"/>
+          <a:chExt cx="0" cy="0"/>
+        </a:xfrm>
+      </p:grpSpPr>
+      <p:sp>
+        <p:nvSpPr>
+          <p:cNvPr id="2" name="제목 1">
+            <a:extLst>
+              <a:ext uri="{FF2B5EF4-FFF2-40B4-BE49-F238E27FC236}">
+                <a16:creationId xmlns:a16="http://schemas.microsoft.com/office/drawing/2014/main" id="{0EEB779C-0825-BC28-AEAE-92935001027C}"/>
+              </a:ext>
+            </a:extLst>
+          </p:cNvPr>
+          <p:cNvSpPr>
+            <a:spLocks noGrp="1"/>
+          </p:cNvSpPr>
+          <p:nvPr>
+            <p:ph type="title"/>
+          </p:nvPr>
+        </p:nvSpPr>
+        <p:spPr/>
+        <p:txBody>
+          <a:bodyPr/>
+          <a:lstStyle/>
+          <a:p>
+            <a:endParaRPr lang="ko-KR" altLang="en-US"/>
+          </a:p>
+        </p:txBody>
+      </p:sp>
+      <p:sp>
+        <p:nvSpPr>
+          <p:cNvPr id="3" name="내용 개체 틀 2">
+            <a:extLst>
+              <a:ext uri="{FF2B5EF4-FFF2-40B4-BE49-F238E27FC236}">
+                <a16:creationId xmlns:a16="http://schemas.microsoft.com/office/drawing/2014/main" id="{624F6D68-F4D9-3E83-0D05-18B228CF7C94}"/>
+              </a:ext>
+            </a:extLst>
+          </p:cNvPr>
+          <p:cNvSpPr>
+            <a:spLocks noGrp="1"/>
+          </p:cNvSpPr>
+          <p:nvPr>
+            <p:ph idx="1"/>
+          </p:nvPr>
+        </p:nvSpPr>
+        <p:spPr/>
+        <p:txBody>
+          <a:bodyPr/>
+          <a:lstStyle/>
+          <a:p>
+            <a:endParaRPr lang="ko-KR" altLang="en-US"/>
+          </a:p>
+        </p:txBody>
+      </p:sp>
+      <p:pic>
+        <p:nvPicPr>
+          <p:cNvPr id="5" name="그림 4">
+            <a:extLst>
+              <a:ext uri="{FF2B5EF4-FFF2-40B4-BE49-F238E27FC236}">
+                <a16:creationId xmlns:a16="http://schemas.microsoft.com/office/drawing/2014/main" id="{09F8A439-CCD9-D3A9-FA3A-D48E9AC4BB2F}"/>
+              </a:ext>
+            </a:extLst>
+          </p:cNvPr>
+          <p:cNvPicPr>
+            <a:picLocks noChangeAspect="1"/>
+          </p:cNvPicPr>
+          <p:nvPr/>
+        </p:nvPicPr>
+        <p:blipFill>
+          <a:blip r:embed="rId2"/>
+          <a:stretch>
+            <a:fillRect/>
+          </a:stretch>
+        </p:blipFill>
+        <p:spPr>
+          <a:xfrm>
+            <a:off x="1202485" y="0"/>
+            <a:ext cx="9787030" cy="6858000"/>
+          </a:xfrm>
+          <a:prstGeom prst="rect">
+            <a:avLst/>
+          </a:prstGeom>
+          <a:ln>
+            <a:solidFill>
+              <a:schemeClr val="bg1">
+                <a:lumMod val="50000"/>
+              </a:schemeClr>
+            </a:solidFill>
+          </a:ln>
+        </p:spPr>
+      </p:pic>
+    </p:spTree>
+    <p:extLst>
+      <p:ext uri="{BB962C8B-B14F-4D97-AF65-F5344CB8AC3E}">
+        <p14:creationId xmlns:p14="http://schemas.microsoft.com/office/powerpoint/2010/main" val="861741968"/>
+      </p:ext>
+    </p:extLst>
+  </p:cSld>
+  <p:clrMapOvr>
+    <a:masterClrMapping/>
+  </p:clrMapOvr>
+</p:sld>
+</file>
+
+<file path=ppt/slides/slide11.xml><?xml version="1.0" encoding="utf-8"?>
+<p:sld xmlns:a="http://schemas.openxmlformats.org/drawingml/2006/main" xmlns:r="http://schemas.openxmlformats.org/officeDocument/2006/relationships" xmlns:p="http://schemas.openxmlformats.org/presentationml/2006/main">
+  <p:cSld>
+    <p:spTree>
+      <p:nvGrpSpPr>
+        <p:cNvPr id="1" name=""/>
+        <p:cNvGrpSpPr/>
+        <p:nvPr/>
+      </p:nvGrpSpPr>
+      <p:grpSpPr>
+        <a:xfrm>
+          <a:off x="0" y="0"/>
+          <a:ext cx="0" cy="0"/>
+          <a:chOff x="0" y="0"/>
+          <a:chExt cx="0" cy="0"/>
+        </a:xfrm>
+      </p:grpSpPr>
+      <p:sp>
+        <p:nvSpPr>
+          <p:cNvPr id="2" name="제목 1">
+            <a:extLst>
+              <a:ext uri="{FF2B5EF4-FFF2-40B4-BE49-F238E27FC236}">
+                <a16:creationId xmlns:a16="http://schemas.microsoft.com/office/drawing/2014/main" id="{850546A1-FCD5-5801-1854-0ECEDEC007A8}"/>
+              </a:ext>
+            </a:extLst>
+          </p:cNvPr>
+          <p:cNvSpPr>
+            <a:spLocks noGrp="1"/>
+          </p:cNvSpPr>
+          <p:nvPr>
+            <p:ph type="title"/>
+          </p:nvPr>
+        </p:nvSpPr>
+        <p:spPr/>
+        <p:txBody>
+          <a:bodyPr/>
+          <a:lstStyle/>
+          <a:p>
+            <a:endParaRPr lang="ko-KR" altLang="en-US"/>
+          </a:p>
+        </p:txBody>
+      </p:sp>
+      <p:sp>
+        <p:nvSpPr>
+          <p:cNvPr id="3" name="내용 개체 틀 2">
+            <a:extLst>
+              <a:ext uri="{FF2B5EF4-FFF2-40B4-BE49-F238E27FC236}">
+                <a16:creationId xmlns:a16="http://schemas.microsoft.com/office/drawing/2014/main" id="{7EBC1D7A-D4EE-2D11-00EF-583AF3387C01}"/>
+              </a:ext>
+            </a:extLst>
+          </p:cNvPr>
+          <p:cNvSpPr>
+            <a:spLocks noGrp="1"/>
+          </p:cNvSpPr>
+          <p:nvPr>
+            <p:ph idx="1"/>
+          </p:nvPr>
+        </p:nvSpPr>
+        <p:spPr/>
+        <p:txBody>
+          <a:bodyPr/>
+          <a:lstStyle/>
+          <a:p>
+            <a:endParaRPr lang="ko-KR" altLang="en-US"/>
+          </a:p>
+        </p:txBody>
+      </p:sp>
+      <p:pic>
+        <p:nvPicPr>
+          <p:cNvPr id="5" name="그림 4">
+            <a:extLst>
+              <a:ext uri="{FF2B5EF4-FFF2-40B4-BE49-F238E27FC236}">
+                <a16:creationId xmlns:a16="http://schemas.microsoft.com/office/drawing/2014/main" id="{E4E5C907-055A-FB63-1428-F49E1DE22A51}"/>
+              </a:ext>
+            </a:extLst>
+          </p:cNvPr>
+          <p:cNvPicPr>
+            <a:picLocks noChangeAspect="1"/>
+          </p:cNvPicPr>
+          <p:nvPr/>
+        </p:nvPicPr>
+        <p:blipFill>
+          <a:blip r:embed="rId2"/>
+          <a:stretch>
+            <a:fillRect/>
+          </a:stretch>
+        </p:blipFill>
+        <p:spPr>
+          <a:xfrm>
+            <a:off x="1151860" y="0"/>
+            <a:ext cx="9888279" cy="6858000"/>
+          </a:xfrm>
+          <a:prstGeom prst="rect">
+            <a:avLst/>
+          </a:prstGeom>
+          <a:ln>
+            <a:solidFill>
+              <a:schemeClr val="bg1">
+                <a:lumMod val="50000"/>
+              </a:schemeClr>
+            </a:solidFill>
+          </a:ln>
+        </p:spPr>
+      </p:pic>
+    </p:spTree>
+    <p:extLst>
+      <p:ext uri="{BB962C8B-B14F-4D97-AF65-F5344CB8AC3E}">
+        <p14:creationId xmlns:p14="http://schemas.microsoft.com/office/powerpoint/2010/main" val="39534546"/>
+      </p:ext>
+    </p:extLst>
+  </p:cSld>
+  <p:clrMapOvr>
+    <a:masterClrMapping/>
+  </p:clrMapOvr>
+</p:sld>
+</file>
+
+<file path=ppt/slides/slide12.xml><?xml version="1.0" encoding="utf-8"?>
+<p:sld xmlns:a="http://schemas.openxmlformats.org/drawingml/2006/main" xmlns:r="http://schemas.openxmlformats.org/officeDocument/2006/relationships" xmlns:p="http://schemas.openxmlformats.org/presentationml/2006/main">
+  <p:cSld>
+    <p:spTree>
+      <p:nvGrpSpPr>
+        <p:cNvPr id="1" name=""/>
+        <p:cNvGrpSpPr/>
+        <p:nvPr/>
+      </p:nvGrpSpPr>
+      <p:grpSpPr>
+        <a:xfrm>
+          <a:off x="0" y="0"/>
+          <a:ext cx="0" cy="0"/>
+          <a:chOff x="0" y="0"/>
+          <a:chExt cx="0" cy="0"/>
+        </a:xfrm>
+      </p:grpSpPr>
+      <p:sp>
+        <p:nvSpPr>
+          <p:cNvPr id="2" name="제목 1">
+            <a:extLst>
+              <a:ext uri="{FF2B5EF4-FFF2-40B4-BE49-F238E27FC236}">
+                <a16:creationId xmlns:a16="http://schemas.microsoft.com/office/drawing/2014/main" id="{802D034D-6AF5-13A4-E1DA-9E1A5F4971E7}"/>
+              </a:ext>
+            </a:extLst>
+          </p:cNvPr>
+          <p:cNvSpPr>
+            <a:spLocks noGrp="1"/>
+          </p:cNvSpPr>
+          <p:nvPr>
+            <p:ph type="title"/>
+          </p:nvPr>
+        </p:nvSpPr>
+        <p:spPr/>
+        <p:txBody>
+          <a:bodyPr/>
+          <a:lstStyle/>
+          <a:p>
+            <a:endParaRPr lang="ko-KR" altLang="en-US"/>
+          </a:p>
+        </p:txBody>
+      </p:sp>
+      <p:sp>
+        <p:nvSpPr>
+          <p:cNvPr id="3" name="내용 개체 틀 2">
+            <a:extLst>
+              <a:ext uri="{FF2B5EF4-FFF2-40B4-BE49-F238E27FC236}">
+                <a16:creationId xmlns:a16="http://schemas.microsoft.com/office/drawing/2014/main" id="{D32B79C4-10C9-54D8-9824-83A6D1C1541D}"/>
+              </a:ext>
+            </a:extLst>
+          </p:cNvPr>
+          <p:cNvSpPr>
+            <a:spLocks noGrp="1"/>
+          </p:cNvSpPr>
+          <p:nvPr>
+            <p:ph idx="1"/>
+          </p:nvPr>
+        </p:nvSpPr>
+        <p:spPr/>
+        <p:txBody>
+          <a:bodyPr/>
+          <a:lstStyle/>
+          <a:p>
+            <a:endParaRPr lang="ko-KR" altLang="en-US"/>
+          </a:p>
+        </p:txBody>
+      </p:sp>
+      <p:pic>
+        <p:nvPicPr>
+          <p:cNvPr id="5" name="그림 4">
+            <a:extLst>
+              <a:ext uri="{FF2B5EF4-FFF2-40B4-BE49-F238E27FC236}">
+                <a16:creationId xmlns:a16="http://schemas.microsoft.com/office/drawing/2014/main" id="{F66728A3-E049-6A90-0CDC-129F74A5D227}"/>
+              </a:ext>
+            </a:extLst>
+          </p:cNvPr>
+          <p:cNvPicPr>
+            <a:picLocks noChangeAspect="1"/>
+          </p:cNvPicPr>
+          <p:nvPr/>
+        </p:nvPicPr>
+        <p:blipFill>
+          <a:blip r:embed="rId2"/>
+          <a:stretch>
+            <a:fillRect/>
+          </a:stretch>
+        </p:blipFill>
+        <p:spPr>
+          <a:xfrm>
+            <a:off x="1778858" y="0"/>
+            <a:ext cx="8634283" cy="6858000"/>
+          </a:xfrm>
+          <a:prstGeom prst="rect">
+            <a:avLst/>
+          </a:prstGeom>
+          <a:ln>
+            <a:solidFill>
+              <a:schemeClr val="bg1">
+                <a:lumMod val="50000"/>
+              </a:schemeClr>
+            </a:solidFill>
+          </a:ln>
+        </p:spPr>
+      </p:pic>
+    </p:spTree>
+    <p:extLst>
+      <p:ext uri="{BB962C8B-B14F-4D97-AF65-F5344CB8AC3E}">
+        <p14:creationId xmlns:p14="http://schemas.microsoft.com/office/powerpoint/2010/main" val="3081685535"/>
+      </p:ext>
+    </p:extLst>
+  </p:cSld>
+  <p:clrMapOvr>
+    <a:masterClrMapping/>
+  </p:clrMapOvr>
+</p:sld>
+</file>
+
+<file path=ppt/slides/slide13.xml><?xml version="1.0" encoding="utf-8"?>
+<p:sld xmlns:a="http://schemas.openxmlformats.org/drawingml/2006/main" xmlns:r="http://schemas.openxmlformats.org/officeDocument/2006/relationships" xmlns:p="http://schemas.openxmlformats.org/presentationml/2006/main">
+  <p:cSld>
+    <p:spTree>
+      <p:nvGrpSpPr>
+        <p:cNvPr id="1" name=""/>
+        <p:cNvGrpSpPr/>
+        <p:nvPr/>
+      </p:nvGrpSpPr>
+      <p:grpSpPr>
+        <a:xfrm>
+          <a:off x="0" y="0"/>
+          <a:ext cx="0" cy="0"/>
+          <a:chOff x="0" y="0"/>
+          <a:chExt cx="0" cy="0"/>
+        </a:xfrm>
+      </p:grpSpPr>
+      <p:sp>
+        <p:nvSpPr>
+          <p:cNvPr id="2" name="제목 1">
+            <a:extLst>
+              <a:ext uri="{FF2B5EF4-FFF2-40B4-BE49-F238E27FC236}">
+                <a16:creationId xmlns:a16="http://schemas.microsoft.com/office/drawing/2014/main" id="{4EA081D9-0B2A-2B3F-333F-3B0BDA1725F7}"/>
+              </a:ext>
+            </a:extLst>
+          </p:cNvPr>
+          <p:cNvSpPr>
+            <a:spLocks noGrp="1"/>
+          </p:cNvSpPr>
+          <p:nvPr>
+            <p:ph type="title"/>
+          </p:nvPr>
+        </p:nvSpPr>
+        <p:spPr/>
+        <p:txBody>
+          <a:bodyPr/>
+          <a:lstStyle/>
+          <a:p>
+            <a:endParaRPr lang="ko-KR" altLang="en-US"/>
+          </a:p>
+        </p:txBody>
+      </p:sp>
+      <p:sp>
+        <p:nvSpPr>
+          <p:cNvPr id="3" name="내용 개체 틀 2">
+            <a:extLst>
+              <a:ext uri="{FF2B5EF4-FFF2-40B4-BE49-F238E27FC236}">
+                <a16:creationId xmlns:a16="http://schemas.microsoft.com/office/drawing/2014/main" id="{567A1178-544D-6595-A8CF-C8AEA1BA3E4E}"/>
+              </a:ext>
+            </a:extLst>
+          </p:cNvPr>
+          <p:cNvSpPr>
+            <a:spLocks noGrp="1"/>
+          </p:cNvSpPr>
+          <p:nvPr>
+            <p:ph idx="1"/>
+          </p:nvPr>
+        </p:nvSpPr>
+        <p:spPr/>
+        <p:txBody>
+          <a:bodyPr/>
+          <a:lstStyle/>
+          <a:p>
+            <a:endParaRPr lang="ko-KR" altLang="en-US"/>
+          </a:p>
+        </p:txBody>
+      </p:sp>
+      <p:pic>
+        <p:nvPicPr>
+          <p:cNvPr id="5" name="그림 4">
+            <a:extLst>
+              <a:ext uri="{FF2B5EF4-FFF2-40B4-BE49-F238E27FC236}">
+                <a16:creationId xmlns:a16="http://schemas.microsoft.com/office/drawing/2014/main" id="{B86A4D6D-C99D-49AF-201F-6B402441A717}"/>
+              </a:ext>
+            </a:extLst>
+          </p:cNvPr>
+          <p:cNvPicPr>
+            <a:picLocks noChangeAspect="1"/>
+          </p:cNvPicPr>
+          <p:nvPr/>
+        </p:nvPicPr>
+        <p:blipFill>
+          <a:blip r:embed="rId2"/>
+          <a:stretch>
+            <a:fillRect/>
+          </a:stretch>
+        </p:blipFill>
+        <p:spPr>
+          <a:xfrm>
+            <a:off x="1586296" y="0"/>
+            <a:ext cx="9019408" cy="6858000"/>
+          </a:xfrm>
+          <a:prstGeom prst="rect">
+            <a:avLst/>
+          </a:prstGeom>
+          <a:ln>
+            <a:solidFill>
+              <a:schemeClr val="bg1">
+                <a:lumMod val="50000"/>
+              </a:schemeClr>
+            </a:solidFill>
+          </a:ln>
+        </p:spPr>
+      </p:pic>
+    </p:spTree>
+    <p:extLst>
+      <p:ext uri="{BB962C8B-B14F-4D97-AF65-F5344CB8AC3E}">
+        <p14:creationId xmlns:p14="http://schemas.microsoft.com/office/powerpoint/2010/main" val="7217532"/>
+      </p:ext>
+    </p:extLst>
+  </p:cSld>
+  <p:clrMapOvr>
+    <a:masterClrMapping/>
+  </p:clrMapOvr>
+</p:sld>
+</file>
+
+<file path=ppt/slides/slide14.xml><?xml version="1.0" encoding="utf-8"?>
+<p:sld xmlns:a="http://schemas.openxmlformats.org/drawingml/2006/main" xmlns:r="http://schemas.openxmlformats.org/officeDocument/2006/relationships" xmlns:p="http://schemas.openxmlformats.org/presentationml/2006/main">
+  <p:cSld>
+    <p:spTree>
+      <p:nvGrpSpPr>
+        <p:cNvPr id="1" name=""/>
+        <p:cNvGrpSpPr/>
+        <p:nvPr/>
+      </p:nvGrpSpPr>
+      <p:grpSpPr>
+        <a:xfrm>
+          <a:off x="0" y="0"/>
+          <a:ext cx="0" cy="0"/>
+          <a:chOff x="0" y="0"/>
+          <a:chExt cx="0" cy="0"/>
+        </a:xfrm>
+      </p:grpSpPr>
+      <p:sp>
+        <p:nvSpPr>
+          <p:cNvPr id="2" name="제목 1">
+            <a:extLst>
+              <a:ext uri="{FF2B5EF4-FFF2-40B4-BE49-F238E27FC236}">
+                <a16:creationId xmlns:a16="http://schemas.microsoft.com/office/drawing/2014/main" id="{705297D7-A058-87DB-5962-43FC33432A03}"/>
+              </a:ext>
+            </a:extLst>
+          </p:cNvPr>
+          <p:cNvSpPr>
+            <a:spLocks noGrp="1"/>
+          </p:cNvSpPr>
+          <p:nvPr>
+            <p:ph type="title"/>
+          </p:nvPr>
+        </p:nvSpPr>
+        <p:spPr/>
+        <p:txBody>
+          <a:bodyPr/>
+          <a:lstStyle/>
+          <a:p>
+            <a:endParaRPr lang="ko-KR" altLang="en-US"/>
+          </a:p>
+        </p:txBody>
+      </p:sp>
+      <p:sp>
+        <p:nvSpPr>
+          <p:cNvPr id="3" name="내용 개체 틀 2">
+            <a:extLst>
+              <a:ext uri="{FF2B5EF4-FFF2-40B4-BE49-F238E27FC236}">
+                <a16:creationId xmlns:a16="http://schemas.microsoft.com/office/drawing/2014/main" id="{BE5DD0A7-3E60-84B3-EE29-755189A5EA64}"/>
+              </a:ext>
+            </a:extLst>
+          </p:cNvPr>
+          <p:cNvSpPr>
+            <a:spLocks noGrp="1"/>
+          </p:cNvSpPr>
+          <p:nvPr>
+            <p:ph idx="1"/>
+          </p:nvPr>
+        </p:nvSpPr>
+        <p:spPr/>
+        <p:txBody>
+          <a:bodyPr/>
+          <a:lstStyle/>
+          <a:p>
+            <a:endParaRPr lang="ko-KR" altLang="en-US"/>
+          </a:p>
+        </p:txBody>
+      </p:sp>
+      <p:pic>
+        <p:nvPicPr>
+          <p:cNvPr id="5" name="그림 4">
+            <a:extLst>
+              <a:ext uri="{FF2B5EF4-FFF2-40B4-BE49-F238E27FC236}">
+                <a16:creationId xmlns:a16="http://schemas.microsoft.com/office/drawing/2014/main" id="{2C170D42-EEE7-0463-1A57-ADEE87F1CDA8}"/>
+              </a:ext>
+            </a:extLst>
+          </p:cNvPr>
+          <p:cNvPicPr>
+            <a:picLocks noChangeAspect="1"/>
+          </p:cNvPicPr>
+          <p:nvPr/>
+        </p:nvPicPr>
+        <p:blipFill>
+          <a:blip r:embed="rId2"/>
+          <a:stretch>
+            <a:fillRect/>
+          </a:stretch>
+        </p:blipFill>
+        <p:spPr>
+          <a:xfrm>
+            <a:off x="1349815" y="0"/>
+            <a:ext cx="9492370" cy="6858000"/>
+          </a:xfrm>
+          <a:prstGeom prst="rect">
+            <a:avLst/>
+          </a:prstGeom>
+          <a:ln>
+            <a:solidFill>
+              <a:schemeClr val="bg1">
+                <a:lumMod val="50000"/>
+              </a:schemeClr>
+            </a:solidFill>
+          </a:ln>
+        </p:spPr>
+      </p:pic>
+    </p:spTree>
+    <p:extLst>
+      <p:ext uri="{BB962C8B-B14F-4D97-AF65-F5344CB8AC3E}">
+        <p14:creationId xmlns:p14="http://schemas.microsoft.com/office/powerpoint/2010/main" val="151827556"/>
+      </p:ext>
+    </p:extLst>
+  </p:cSld>
+  <p:clrMapOvr>
+    <a:masterClrMapping/>
+  </p:clrMapOvr>
+</p:sld>
+</file>
+
 <file path=ppt/slides/slide2.xml><?xml version="1.0" encoding="utf-8"?>
 <p:sld xmlns:a="http://schemas.openxmlformats.org/drawingml/2006/main" xmlns:r="http://schemas.openxmlformats.org/officeDocument/2006/relationships" xmlns:p="http://schemas.openxmlformats.org/presentationml/2006/main">
   <p:cSld>
@@ -40769,7 +41506,7 @@
         </p:blipFill>
         <p:spPr>
           <a:xfrm>
-            <a:off x="461176" y="3033657"/>
+            <a:off x="461176" y="1018044"/>
             <a:ext cx="11269648" cy="790685"/>
           </a:xfrm>
           <a:prstGeom prst="rect">
@@ -40791,7 +41528,7 @@
         </p:nvSpPr>
         <p:spPr>
           <a:xfrm>
-            <a:off x="1691303" y="3535292"/>
+            <a:off x="1691303" y="1519679"/>
             <a:ext cx="413722" cy="160408"/>
           </a:xfrm>
           <a:prstGeom prst="rect">
@@ -40872,7 +41609,7 @@
         </p:nvSpPr>
         <p:spPr>
           <a:xfrm>
-            <a:off x="3767753" y="3374884"/>
+            <a:off x="3767753" y="1359271"/>
             <a:ext cx="413722" cy="160408"/>
           </a:xfrm>
           <a:prstGeom prst="rect">
@@ -40953,7 +41690,7 @@
         </p:nvSpPr>
         <p:spPr>
           <a:xfrm>
-            <a:off x="1240488" y="3181883"/>
+            <a:off x="1240488" y="1166270"/>
             <a:ext cx="940737" cy="273205"/>
           </a:xfrm>
           <a:prstGeom prst="roundRect">
@@ -41013,7 +41750,7 @@
         </p:blipFill>
         <p:spPr>
           <a:xfrm>
-            <a:off x="2105025" y="3376430"/>
+            <a:off x="2105025" y="1360817"/>
             <a:ext cx="180622" cy="214489"/>
           </a:xfrm>
           <a:prstGeom prst="rect">
@@ -41021,6 +41758,199 @@
           </a:prstGeom>
         </p:spPr>
       </p:pic>
+      <p:pic>
+        <p:nvPicPr>
+          <p:cNvPr id="14" name="그림 13">
+            <a:extLst>
+              <a:ext uri="{FF2B5EF4-FFF2-40B4-BE49-F238E27FC236}">
+                <a16:creationId xmlns:a16="http://schemas.microsoft.com/office/drawing/2014/main" id="{5BBC49ED-5FBB-9032-DBF6-B6DF5726A3D1}"/>
+              </a:ext>
+            </a:extLst>
+          </p:cNvPr>
+          <p:cNvPicPr>
+            <a:picLocks noChangeAspect="1"/>
+          </p:cNvPicPr>
+          <p:nvPr/>
+        </p:nvPicPr>
+        <p:blipFill>
+          <a:blip r:embed="rId4"/>
+          <a:stretch>
+            <a:fillRect/>
+          </a:stretch>
+        </p:blipFill>
+        <p:spPr>
+          <a:xfrm>
+            <a:off x="461176" y="2151502"/>
+            <a:ext cx="2715004" cy="5191850"/>
+          </a:xfrm>
+          <a:prstGeom prst="rect">
+            <a:avLst/>
+          </a:prstGeom>
+        </p:spPr>
+      </p:pic>
+      <p:sp>
+        <p:nvSpPr>
+          <p:cNvPr id="15" name="사각형: 둥근 모서리 14">
+            <a:extLst>
+              <a:ext uri="{FF2B5EF4-FFF2-40B4-BE49-F238E27FC236}">
+                <a16:creationId xmlns:a16="http://schemas.microsoft.com/office/drawing/2014/main" id="{B1D90B6C-02CD-90EE-D948-E49CC7BA57B5}"/>
+              </a:ext>
+            </a:extLst>
+          </p:cNvPr>
+          <p:cNvSpPr/>
+          <p:nvPr/>
+        </p:nvSpPr>
+        <p:spPr>
+          <a:xfrm>
+            <a:off x="1938578" y="3379840"/>
+            <a:ext cx="940737" cy="273205"/>
+          </a:xfrm>
+          <a:prstGeom prst="roundRect">
+            <a:avLst/>
+          </a:prstGeom>
+          <a:noFill/>
+          <a:ln w="19050">
+            <a:solidFill>
+              <a:srgbClr val="0093A2"/>
+            </a:solidFill>
+          </a:ln>
+        </p:spPr>
+        <p:style>
+          <a:lnRef idx="2">
+            <a:schemeClr val="accent1">
+              <a:shade val="15000"/>
+            </a:schemeClr>
+          </a:lnRef>
+          <a:fillRef idx="1">
+            <a:schemeClr val="accent1"/>
+          </a:fillRef>
+          <a:effectRef idx="0">
+            <a:schemeClr val="accent1"/>
+          </a:effectRef>
+          <a:fontRef idx="minor">
+            <a:schemeClr val="lt1"/>
+          </a:fontRef>
+        </p:style>
+        <p:txBody>
+          <a:bodyPr rtlCol="0" anchor="ctr"/>
+          <a:lstStyle/>
+          <a:p>
+            <a:pPr algn="ctr"/>
+            <a:endParaRPr lang="ko-KR" altLang="en-US"/>
+          </a:p>
+        </p:txBody>
+      </p:sp>
+      <p:pic>
+        <p:nvPicPr>
+          <p:cNvPr id="16" name="그림 15">
+            <a:extLst>
+              <a:ext uri="{FF2B5EF4-FFF2-40B4-BE49-F238E27FC236}">
+                <a16:creationId xmlns:a16="http://schemas.microsoft.com/office/drawing/2014/main" id="{8E510375-6981-5337-504F-272B07192137}"/>
+              </a:ext>
+            </a:extLst>
+          </p:cNvPr>
+          <p:cNvPicPr>
+            <a:picLocks noChangeAspect="1"/>
+          </p:cNvPicPr>
+          <p:nvPr/>
+        </p:nvPicPr>
+        <p:blipFill>
+          <a:blip r:embed="rId3"/>
+          <a:stretch>
+            <a:fillRect/>
+          </a:stretch>
+        </p:blipFill>
+        <p:spPr>
+          <a:xfrm>
+            <a:off x="2803115" y="3574387"/>
+            <a:ext cx="180622" cy="214489"/>
+          </a:xfrm>
+          <a:prstGeom prst="rect">
+            <a:avLst/>
+          </a:prstGeom>
+        </p:spPr>
+      </p:pic>
+      <p:sp>
+        <p:nvSpPr>
+          <p:cNvPr id="17" name="직사각형 16">
+            <a:extLst>
+              <a:ext uri="{FF2B5EF4-FFF2-40B4-BE49-F238E27FC236}">
+                <a16:creationId xmlns:a16="http://schemas.microsoft.com/office/drawing/2014/main" id="{C4FAD7A7-0F1B-7E16-5798-9E7DBC28CCA9}"/>
+              </a:ext>
+            </a:extLst>
+          </p:cNvPr>
+          <p:cNvSpPr/>
+          <p:nvPr/>
+        </p:nvSpPr>
+        <p:spPr>
+          <a:xfrm>
+            <a:off x="1503995" y="4255599"/>
+            <a:ext cx="1299120" cy="149424"/>
+          </a:xfrm>
+          <a:prstGeom prst="rect">
+            <a:avLst/>
+          </a:prstGeom>
+          <a:solidFill>
+            <a:srgbClr val="F2F2F2"/>
+          </a:solidFill>
+          <a:ln>
+            <a:noFill/>
+          </a:ln>
+        </p:spPr>
+        <p:style>
+          <a:lnRef idx="2">
+            <a:schemeClr val="accent1">
+              <a:shade val="50000"/>
+            </a:schemeClr>
+          </a:lnRef>
+          <a:fillRef idx="1">
+            <a:schemeClr val="accent1"/>
+          </a:fillRef>
+          <a:effectRef idx="0">
+            <a:schemeClr val="accent1"/>
+          </a:effectRef>
+          <a:fontRef idx="minor">
+            <a:schemeClr val="lt1"/>
+          </a:fontRef>
+        </p:style>
+        <p:txBody>
+          <a:bodyPr rtlCol="0" anchor="ctr"/>
+          <a:lstStyle/>
+          <a:p>
+            <a:pPr marL="0" marR="0" lvl="0" indent="0" algn="ctr" defTabSz="914400" rtl="0" eaLnBrk="1" fontAlgn="auto" latinLnBrk="1" hangingPunct="1">
+              <a:lnSpc>
+                <a:spcPct val="100000"/>
+              </a:lnSpc>
+              <a:spcBef>
+                <a:spcPts val="0"/>
+              </a:spcBef>
+              <a:spcAft>
+                <a:spcPts val="0"/>
+              </a:spcAft>
+              <a:buClrTx/>
+              <a:buSzTx/>
+              <a:buFontTx/>
+              <a:buNone/>
+              <a:tabLst/>
+              <a:defRPr/>
+            </a:pPr>
+            <a:endParaRPr kumimoji="0" lang="ko-KR" altLang="en-US" sz="1800" b="0" i="0" u="none" strike="noStrike" kern="1200" cap="none" spc="0" normalizeH="0" baseline="0" noProof="0">
+              <a:ln>
+                <a:noFill/>
+              </a:ln>
+              <a:solidFill>
+                <a:prstClr val="white"/>
+              </a:solidFill>
+              <a:effectLst/>
+              <a:uLnTx/>
+              <a:uFillTx/>
+              <a:latin typeface="Montserrat" pitchFamily="2" charset="0"/>
+              <a:ea typeface="맑은 고딕" panose="020B0503020000020004" pitchFamily="50" charset="-127"/>
+              <a:cs typeface="+mn-cs"/>
+            </a:endParaRPr>
+          </a:p>
+        </p:txBody>
+      </p:sp>
     </p:spTree>
     <p:extLst>
       <p:ext uri="{BB962C8B-B14F-4D97-AF65-F5344CB8AC3E}">
@@ -41147,6 +42077,73 @@
     <p:extLst>
       <p:ext uri="{BB962C8B-B14F-4D97-AF65-F5344CB8AC3E}">
         <p14:creationId xmlns:p14="http://schemas.microsoft.com/office/powerpoint/2010/main" val="708211789"/>
+      </p:ext>
+    </p:extLst>
+  </p:cSld>
+  <p:clrMapOvr>
+    <a:masterClrMapping/>
+  </p:clrMapOvr>
+</p:sld>
+</file>
+
+<file path=ppt/slides/slide9.xml><?xml version="1.0" encoding="utf-8"?>
+<p:sld xmlns:a="http://schemas.openxmlformats.org/drawingml/2006/main" xmlns:r="http://schemas.openxmlformats.org/officeDocument/2006/relationships" xmlns:p="http://schemas.openxmlformats.org/presentationml/2006/main">
+  <p:cSld>
+    <p:spTree>
+      <p:nvGrpSpPr>
+        <p:cNvPr id="1" name=""/>
+        <p:cNvGrpSpPr/>
+        <p:nvPr/>
+      </p:nvGrpSpPr>
+      <p:grpSpPr>
+        <a:xfrm>
+          <a:off x="0" y="0"/>
+          <a:ext cx="0" cy="0"/>
+          <a:chOff x="0" y="0"/>
+          <a:chExt cx="0" cy="0"/>
+        </a:xfrm>
+      </p:grpSpPr>
+      <p:pic>
+        <p:nvPicPr>
+          <p:cNvPr id="5" name="그림 4">
+            <a:extLst>
+              <a:ext uri="{FF2B5EF4-FFF2-40B4-BE49-F238E27FC236}">
+                <a16:creationId xmlns:a16="http://schemas.microsoft.com/office/drawing/2014/main" id="{376F8DE8-B3D5-3EFB-E1C5-850A5BA0A308}"/>
+              </a:ext>
+            </a:extLst>
+          </p:cNvPr>
+          <p:cNvPicPr>
+            <a:picLocks noChangeAspect="1"/>
+          </p:cNvPicPr>
+          <p:nvPr/>
+        </p:nvPicPr>
+        <p:blipFill>
+          <a:blip r:embed="rId2"/>
+          <a:stretch>
+            <a:fillRect/>
+          </a:stretch>
+        </p:blipFill>
+        <p:spPr>
+          <a:xfrm>
+            <a:off x="1327501" y="0"/>
+            <a:ext cx="5783982" cy="6858000"/>
+          </a:xfrm>
+          <a:prstGeom prst="rect">
+            <a:avLst/>
+          </a:prstGeom>
+          <a:ln>
+            <a:solidFill>
+              <a:schemeClr val="bg1">
+                <a:lumMod val="50000"/>
+              </a:schemeClr>
+            </a:solidFill>
+          </a:ln>
+        </p:spPr>
+      </p:pic>
+    </p:spTree>
+    <p:extLst>
+      <p:ext uri="{BB962C8B-B14F-4D97-AF65-F5344CB8AC3E}">
+        <p14:creationId xmlns:p14="http://schemas.microsoft.com/office/powerpoint/2010/main" val="1939488093"/>
       </p:ext>
     </p:extLst>
   </p:cSld>

</xml_diff>